<commit_message>
chore(branding): refresh logo assets [refs #450]
</commit_message>
<xml_diff>
--- a/docs/assets/logo.pptx
+++ b/docs/assets/logo.pptx
@@ -7,6 +7,7 @@
   <p:sldIdLst>
     <p:sldId id="256" r:id="rId2"/>
     <p:sldId id="257" r:id="rId3"/>
+    <p:sldId id="258" r:id="rId4"/>
   </p:sldIdLst>
   <p:sldSz cx="7945438" cy="2898775"/>
   <p:notesSz cx="6858000" cy="9144000"/>
@@ -244,7 +245,7 @@
           <a:p>
             <a:fld id="{27277734-DF0B-5A45-B070-6F76D1CD3B34}" type="datetimeFigureOut">
               <a:rPr kumimoji="1" lang="ja-JP" altLang="en-US" smtClean="0"/>
-              <a:t>2025/11/1</a:t>
+              <a:t>2025/12/22</a:t>
             </a:fld>
             <a:endParaRPr kumimoji="1" lang="ja-JP" altLang="en-US"/>
           </a:p>
@@ -446,7 +447,7 @@
           <a:p>
             <a:fld id="{27277734-DF0B-5A45-B070-6F76D1CD3B34}" type="datetimeFigureOut">
               <a:rPr kumimoji="1" lang="ja-JP" altLang="en-US" smtClean="0"/>
-              <a:t>2025/11/1</a:t>
+              <a:t>2025/12/22</a:t>
             </a:fld>
             <a:endParaRPr kumimoji="1" lang="ja-JP" altLang="en-US"/>
           </a:p>
@@ -658,7 +659,7 @@
           <a:p>
             <a:fld id="{27277734-DF0B-5A45-B070-6F76D1CD3B34}" type="datetimeFigureOut">
               <a:rPr kumimoji="1" lang="ja-JP" altLang="en-US" smtClean="0"/>
-              <a:t>2025/11/1</a:t>
+              <a:t>2025/12/22</a:t>
             </a:fld>
             <a:endParaRPr kumimoji="1" lang="ja-JP" altLang="en-US"/>
           </a:p>
@@ -860,7 +861,7 @@
           <a:p>
             <a:fld id="{27277734-DF0B-5A45-B070-6F76D1CD3B34}" type="datetimeFigureOut">
               <a:rPr kumimoji="1" lang="ja-JP" altLang="en-US" smtClean="0"/>
-              <a:t>2025/11/1</a:t>
+              <a:t>2025/12/22</a:t>
             </a:fld>
             <a:endParaRPr kumimoji="1" lang="ja-JP" altLang="en-US"/>
           </a:p>
@@ -1106,7 +1107,7 @@
           <a:p>
             <a:fld id="{27277734-DF0B-5A45-B070-6F76D1CD3B34}" type="datetimeFigureOut">
               <a:rPr kumimoji="1" lang="ja-JP" altLang="en-US" smtClean="0"/>
-              <a:t>2025/11/1</a:t>
+              <a:t>2025/12/22</a:t>
             </a:fld>
             <a:endParaRPr kumimoji="1" lang="ja-JP" altLang="en-US"/>
           </a:p>
@@ -1402,7 +1403,7 @@
           <a:p>
             <a:fld id="{27277734-DF0B-5A45-B070-6F76D1CD3B34}" type="datetimeFigureOut">
               <a:rPr kumimoji="1" lang="ja-JP" altLang="en-US" smtClean="0"/>
-              <a:t>2025/11/1</a:t>
+              <a:t>2025/12/22</a:t>
             </a:fld>
             <a:endParaRPr kumimoji="1" lang="ja-JP" altLang="en-US"/>
           </a:p>
@@ -1833,7 +1834,7 @@
           <a:p>
             <a:fld id="{27277734-DF0B-5A45-B070-6F76D1CD3B34}" type="datetimeFigureOut">
               <a:rPr kumimoji="1" lang="ja-JP" altLang="en-US" smtClean="0"/>
-              <a:t>2025/11/1</a:t>
+              <a:t>2025/12/22</a:t>
             </a:fld>
             <a:endParaRPr kumimoji="1" lang="ja-JP" altLang="en-US"/>
           </a:p>
@@ -1951,7 +1952,7 @@
           <a:p>
             <a:fld id="{27277734-DF0B-5A45-B070-6F76D1CD3B34}" type="datetimeFigureOut">
               <a:rPr kumimoji="1" lang="ja-JP" altLang="en-US" smtClean="0"/>
-              <a:t>2025/11/1</a:t>
+              <a:t>2025/12/22</a:t>
             </a:fld>
             <a:endParaRPr kumimoji="1" lang="ja-JP" altLang="en-US"/>
           </a:p>
@@ -2046,7 +2047,7 @@
           <a:p>
             <a:fld id="{27277734-DF0B-5A45-B070-6F76D1CD3B34}" type="datetimeFigureOut">
               <a:rPr kumimoji="1" lang="ja-JP" altLang="en-US" smtClean="0"/>
-              <a:t>2025/11/1</a:t>
+              <a:t>2025/12/22</a:t>
             </a:fld>
             <a:endParaRPr kumimoji="1" lang="ja-JP" altLang="en-US"/>
           </a:p>
@@ -2355,7 +2356,7 @@
           <a:p>
             <a:fld id="{27277734-DF0B-5A45-B070-6F76D1CD3B34}" type="datetimeFigureOut">
               <a:rPr kumimoji="1" lang="ja-JP" altLang="en-US" smtClean="0"/>
-              <a:t>2025/11/1</a:t>
+              <a:t>2025/12/22</a:t>
             </a:fld>
             <a:endParaRPr kumimoji="1" lang="ja-JP" altLang="en-US"/>
           </a:p>
@@ -2612,7 +2613,7 @@
           <a:p>
             <a:fld id="{27277734-DF0B-5A45-B070-6F76D1CD3B34}" type="datetimeFigureOut">
               <a:rPr kumimoji="1" lang="ja-JP" altLang="en-US" smtClean="0"/>
-              <a:t>2025/11/1</a:t>
+              <a:t>2025/12/22</a:t>
             </a:fld>
             <a:endParaRPr kumimoji="1" lang="ja-JP" altLang="en-US"/>
           </a:p>
@@ -2857,7 +2858,7 @@
           <a:p>
             <a:fld id="{27277734-DF0B-5A45-B070-6F76D1CD3B34}" type="datetimeFigureOut">
               <a:rPr kumimoji="1" lang="ja-JP" altLang="en-US" smtClean="0"/>
-              <a:t>2025/11/1</a:t>
+              <a:t>2025/12/22</a:t>
             </a:fld>
             <a:endParaRPr kumimoji="1" lang="ja-JP" altLang="en-US"/>
           </a:p>
@@ -3897,6 +3898,344 @@
 </p:sld>
 </file>
 
+<file path=ppt/slides/slide3.xml><?xml version="1.0" encoding="utf-8"?>
+<p:sld xmlns:a="http://schemas.openxmlformats.org/drawingml/2006/main" xmlns:r="http://schemas.openxmlformats.org/officeDocument/2006/relationships" xmlns:p="http://schemas.openxmlformats.org/presentationml/2006/main">
+  <p:cSld>
+    <p:spTree>
+      <p:nvGrpSpPr>
+        <p:cNvPr id="1" name=""/>
+        <p:cNvGrpSpPr/>
+        <p:nvPr/>
+      </p:nvGrpSpPr>
+      <p:grpSpPr>
+        <a:xfrm>
+          <a:off x="0" y="0"/>
+          <a:ext cx="0" cy="0"/>
+          <a:chOff x="0" y="0"/>
+          <a:chExt cx="0" cy="0"/>
+        </a:xfrm>
+      </p:grpSpPr>
+      <p:sp>
+        <p:nvSpPr>
+          <p:cNvPr id="5" name="正方形/長方形 4">
+            <a:extLst>
+              <a:ext uri="{FF2B5EF4-FFF2-40B4-BE49-F238E27FC236}">
+                <a16:creationId xmlns:a16="http://schemas.microsoft.com/office/drawing/2014/main" id="{65F09CC6-4E7B-81F0-0FE6-EF1248BC835F}"/>
+              </a:ext>
+            </a:extLst>
+          </p:cNvPr>
+          <p:cNvSpPr/>
+          <p:nvPr/>
+        </p:nvSpPr>
+        <p:spPr>
+          <a:xfrm>
+            <a:off x="94992" y="140679"/>
+            <a:ext cx="1025641" cy="1187939"/>
+          </a:xfrm>
+          <a:prstGeom prst="rect">
+            <a:avLst/>
+          </a:prstGeom>
+          <a:solidFill>
+            <a:schemeClr val="tx1"/>
+          </a:solidFill>
+          <a:ln>
+            <a:noFill/>
+          </a:ln>
+        </p:spPr>
+        <p:style>
+          <a:lnRef idx="2">
+            <a:schemeClr val="accent1">
+              <a:shade val="15000"/>
+            </a:schemeClr>
+          </a:lnRef>
+          <a:fillRef idx="1">
+            <a:schemeClr val="accent1"/>
+          </a:fillRef>
+          <a:effectRef idx="0">
+            <a:schemeClr val="accent1"/>
+          </a:effectRef>
+          <a:fontRef idx="minor">
+            <a:schemeClr val="lt1"/>
+          </a:fontRef>
+        </p:style>
+        <p:txBody>
+          <a:bodyPr rtlCol="0" anchor="ctr"/>
+          <a:lstStyle/>
+          <a:p>
+            <a:pPr algn="ctr"/>
+            <a:endParaRPr kumimoji="1" lang="ja-JP" altLang="en-US"/>
+          </a:p>
+        </p:txBody>
+      </p:sp>
+      <p:sp>
+        <p:nvSpPr>
+          <p:cNvPr id="6" name="角丸四角形 5">
+            <a:extLst>
+              <a:ext uri="{FF2B5EF4-FFF2-40B4-BE49-F238E27FC236}">
+                <a16:creationId xmlns:a16="http://schemas.microsoft.com/office/drawing/2014/main" id="{2D3A37A2-050B-BE0B-8FBA-E5EDBCDF0AA4}"/>
+              </a:ext>
+            </a:extLst>
+          </p:cNvPr>
+          <p:cNvSpPr/>
+          <p:nvPr/>
+        </p:nvSpPr>
+        <p:spPr>
+          <a:xfrm>
+            <a:off x="236216" y="331784"/>
+            <a:ext cx="743191" cy="805728"/>
+          </a:xfrm>
+          <a:prstGeom prst="roundRect">
+            <a:avLst/>
+          </a:prstGeom>
+          <a:noFill/>
+          <a:ln w="12700">
+            <a:solidFill>
+              <a:schemeClr val="bg1"/>
+            </a:solidFill>
+          </a:ln>
+        </p:spPr>
+        <p:style>
+          <a:lnRef idx="2">
+            <a:schemeClr val="accent1">
+              <a:shade val="15000"/>
+            </a:schemeClr>
+          </a:lnRef>
+          <a:fillRef idx="1">
+            <a:schemeClr val="accent1"/>
+          </a:fillRef>
+          <a:effectRef idx="0">
+            <a:schemeClr val="accent1"/>
+          </a:effectRef>
+          <a:fontRef idx="minor">
+            <a:schemeClr val="lt1"/>
+          </a:fontRef>
+        </p:style>
+        <p:txBody>
+          <a:bodyPr rtlCol="0" anchor="ctr"/>
+          <a:lstStyle/>
+          <a:p>
+            <a:pPr algn="ctr"/>
+            <a:endParaRPr kumimoji="1" lang="ja-JP" altLang="en-US"/>
+          </a:p>
+        </p:txBody>
+      </p:sp>
+      <p:sp>
+        <p:nvSpPr>
+          <p:cNvPr id="2" name="タイトル 1">
+            <a:extLst>
+              <a:ext uri="{FF2B5EF4-FFF2-40B4-BE49-F238E27FC236}">
+                <a16:creationId xmlns:a16="http://schemas.microsoft.com/office/drawing/2014/main" id="{87EFA2A9-E6E2-89DC-0F6B-8A5ED67C0B32}"/>
+              </a:ext>
+            </a:extLst>
+          </p:cNvPr>
+          <p:cNvSpPr txBox="1">
+            <a:spLocks/>
+          </p:cNvSpPr>
+          <p:nvPr/>
+        </p:nvSpPr>
+        <p:spPr>
+          <a:xfrm>
+            <a:off x="283122" y="269756"/>
+            <a:ext cx="649380" cy="1058862"/>
+          </a:xfrm>
+          <a:prstGeom prst="rect">
+            <a:avLst/>
+          </a:prstGeom>
+        </p:spPr>
+        <p:txBody>
+          <a:bodyPr anchor="ctr">
+            <a:normAutofit/>
+          </a:bodyPr>
+          <a:lstStyle>
+            <a:lvl1pPr algn="l" defTabSz="386517" rtl="0" eaLnBrk="1" latinLnBrk="0" hangingPunct="1">
+              <a:lnSpc>
+                <a:spcPct val="90000"/>
+              </a:lnSpc>
+              <a:spcBef>
+                <a:spcPct val="0"/>
+              </a:spcBef>
+              <a:buNone/>
+              <a:defRPr kumimoji="1" sz="1860" kern="1200">
+                <a:solidFill>
+                  <a:schemeClr val="tx1"/>
+                </a:solidFill>
+                <a:latin typeface="+mj-lt"/>
+                <a:ea typeface="+mj-ea"/>
+                <a:cs typeface="+mj-cs"/>
+              </a:defRPr>
+            </a:lvl1pPr>
+          </a:lstStyle>
+          <a:p>
+            <a:r>
+              <a:rPr lang="en-US" altLang="ja-JP" sz="6400" b="1" dirty="0">
+                <a:ln>
+                  <a:solidFill>
+                    <a:schemeClr val="bg1">
+                      <a:lumMod val="95000"/>
+                    </a:schemeClr>
+                  </a:solidFill>
+                </a:ln>
+                <a:blipFill dpi="0" rotWithShape="1">
+                  <a:blip r:embed="rId2"/>
+                  <a:srcRect/>
+                  <a:tile tx="0" ty="0" sx="57000" sy="100000" flip="none" algn="tl"/>
+                </a:blipFill>
+                <a:latin typeface="Bauhaus 93" pitchFamily="82" charset="0"/>
+              </a:rPr>
+              <a:t>P</a:t>
+            </a:r>
+            <a:endParaRPr lang="ja-JP" altLang="en-US" sz="6400" b="1">
+              <a:ln>
+                <a:solidFill>
+                  <a:schemeClr val="bg1">
+                    <a:lumMod val="95000"/>
+                  </a:schemeClr>
+                </a:solidFill>
+              </a:ln>
+              <a:blipFill dpi="0" rotWithShape="1">
+                <a:blip r:embed="rId2"/>
+                <a:srcRect/>
+                <a:tile tx="0" ty="0" sx="57000" sy="100000" flip="none" algn="tl"/>
+              </a:blipFill>
+              <a:latin typeface="Bauhaus 93" pitchFamily="82" charset="0"/>
+            </a:endParaRPr>
+          </a:p>
+        </p:txBody>
+      </p:sp>
+      <p:sp>
+        <p:nvSpPr>
+          <p:cNvPr id="4" name="タイトル 1">
+            <a:extLst>
+              <a:ext uri="{FF2B5EF4-FFF2-40B4-BE49-F238E27FC236}">
+                <a16:creationId xmlns:a16="http://schemas.microsoft.com/office/drawing/2014/main" id="{D07071CE-012B-6850-6252-28266B0A8A77}"/>
+              </a:ext>
+            </a:extLst>
+          </p:cNvPr>
+          <p:cNvSpPr txBox="1">
+            <a:spLocks/>
+          </p:cNvSpPr>
+          <p:nvPr/>
+        </p:nvSpPr>
+        <p:spPr>
+          <a:xfrm>
+            <a:off x="1617082" y="269756"/>
+            <a:ext cx="649380" cy="1058862"/>
+          </a:xfrm>
+          <a:prstGeom prst="rect">
+            <a:avLst/>
+          </a:prstGeom>
+        </p:spPr>
+        <p:txBody>
+          <a:bodyPr anchor="ctr">
+            <a:normAutofit/>
+          </a:bodyPr>
+          <a:lstStyle>
+            <a:lvl1pPr algn="l" defTabSz="386517" rtl="0" eaLnBrk="1" latinLnBrk="0" hangingPunct="1">
+              <a:lnSpc>
+                <a:spcPct val="90000"/>
+              </a:lnSpc>
+              <a:spcBef>
+                <a:spcPct val="0"/>
+              </a:spcBef>
+              <a:buNone/>
+              <a:defRPr kumimoji="1" sz="1860" kern="1200">
+                <a:solidFill>
+                  <a:schemeClr val="tx1"/>
+                </a:solidFill>
+                <a:latin typeface="+mj-lt"/>
+                <a:ea typeface="+mj-ea"/>
+                <a:cs typeface="+mj-cs"/>
+              </a:defRPr>
+            </a:lvl1pPr>
+          </a:lstStyle>
+          <a:p>
+            <a:r>
+              <a:rPr lang="en-US" altLang="ja-JP" sz="6400" b="1" dirty="0">
+                <a:blipFill dpi="0" rotWithShape="1">
+                  <a:blip r:embed="rId2"/>
+                  <a:srcRect/>
+                  <a:tile tx="0" ty="0" sx="57000" sy="100000" flip="none" algn="tl"/>
+                </a:blipFill>
+                <a:latin typeface="Bauhaus 93" pitchFamily="82" charset="0"/>
+              </a:rPr>
+              <a:t>P</a:t>
+            </a:r>
+            <a:endParaRPr lang="ja-JP" altLang="en-US" sz="6400" b="1">
+              <a:blipFill dpi="0" rotWithShape="1">
+                <a:blip r:embed="rId2"/>
+                <a:srcRect/>
+                <a:tile tx="0" ty="0" sx="57000" sy="100000" flip="none" algn="tl"/>
+              </a:blipFill>
+              <a:latin typeface="Bauhaus 93" pitchFamily="82" charset="0"/>
+            </a:endParaRPr>
+          </a:p>
+        </p:txBody>
+      </p:sp>
+      <p:sp>
+        <p:nvSpPr>
+          <p:cNvPr id="7" name="角丸四角形 6">
+            <a:extLst>
+              <a:ext uri="{FF2B5EF4-FFF2-40B4-BE49-F238E27FC236}">
+                <a16:creationId xmlns:a16="http://schemas.microsoft.com/office/drawing/2014/main" id="{1617E5BB-C796-8346-FA6E-77538243F623}"/>
+              </a:ext>
+            </a:extLst>
+          </p:cNvPr>
+          <p:cNvSpPr/>
+          <p:nvPr/>
+        </p:nvSpPr>
+        <p:spPr>
+          <a:xfrm>
+            <a:off x="1570176" y="327260"/>
+            <a:ext cx="743191" cy="805728"/>
+          </a:xfrm>
+          <a:prstGeom prst="roundRect">
+            <a:avLst/>
+          </a:prstGeom>
+          <a:noFill/>
+          <a:ln w="12700">
+            <a:solidFill>
+              <a:schemeClr val="tx1"/>
+            </a:solidFill>
+          </a:ln>
+        </p:spPr>
+        <p:style>
+          <a:lnRef idx="2">
+            <a:schemeClr val="accent1">
+              <a:shade val="15000"/>
+            </a:schemeClr>
+          </a:lnRef>
+          <a:fillRef idx="1">
+            <a:schemeClr val="accent1"/>
+          </a:fillRef>
+          <a:effectRef idx="0">
+            <a:schemeClr val="accent1"/>
+          </a:effectRef>
+          <a:fontRef idx="minor">
+            <a:schemeClr val="lt1"/>
+          </a:fontRef>
+        </p:style>
+        <p:txBody>
+          <a:bodyPr rtlCol="0" anchor="ctr"/>
+          <a:lstStyle/>
+          <a:p>
+            <a:pPr algn="ctr"/>
+            <a:endParaRPr kumimoji="1" lang="ja-JP" altLang="en-US"/>
+          </a:p>
+        </p:txBody>
+      </p:sp>
+    </p:spTree>
+    <p:extLst>
+      <p:ext uri="{BB962C8B-B14F-4D97-AF65-F5344CB8AC3E}">
+        <p14:creationId xmlns:p14="http://schemas.microsoft.com/office/powerpoint/2010/main" val="3232208660"/>
+      </p:ext>
+    </p:extLst>
+  </p:cSld>
+  <p:clrMapOvr>
+    <a:masterClrMapping/>
+  </p:clrMapOvr>
+</p:sld>
+</file>
+
 <file path=ppt/theme/theme1.xml><?xml version="1.0" encoding="utf-8"?>
 <a:theme xmlns:a="http://schemas.openxmlformats.org/drawingml/2006/main" name="Office テーマ">
   <a:themeElements>

</xml_diff>

<commit_message>
chore(branding): refresh logo assets [refs #450] (#451)
</commit_message>
<xml_diff>
--- a/docs/assets/logo.pptx
+++ b/docs/assets/logo.pptx
@@ -7,6 +7,7 @@
   <p:sldIdLst>
     <p:sldId id="256" r:id="rId2"/>
     <p:sldId id="257" r:id="rId3"/>
+    <p:sldId id="258" r:id="rId4"/>
   </p:sldIdLst>
   <p:sldSz cx="7945438" cy="2898775"/>
   <p:notesSz cx="6858000" cy="9144000"/>
@@ -244,7 +245,7 @@
           <a:p>
             <a:fld id="{27277734-DF0B-5A45-B070-6F76D1CD3B34}" type="datetimeFigureOut">
               <a:rPr kumimoji="1" lang="ja-JP" altLang="en-US" smtClean="0"/>
-              <a:t>2025/11/1</a:t>
+              <a:t>2025/12/22</a:t>
             </a:fld>
             <a:endParaRPr kumimoji="1" lang="ja-JP" altLang="en-US"/>
           </a:p>
@@ -446,7 +447,7 @@
           <a:p>
             <a:fld id="{27277734-DF0B-5A45-B070-6F76D1CD3B34}" type="datetimeFigureOut">
               <a:rPr kumimoji="1" lang="ja-JP" altLang="en-US" smtClean="0"/>
-              <a:t>2025/11/1</a:t>
+              <a:t>2025/12/22</a:t>
             </a:fld>
             <a:endParaRPr kumimoji="1" lang="ja-JP" altLang="en-US"/>
           </a:p>
@@ -658,7 +659,7 @@
           <a:p>
             <a:fld id="{27277734-DF0B-5A45-B070-6F76D1CD3B34}" type="datetimeFigureOut">
               <a:rPr kumimoji="1" lang="ja-JP" altLang="en-US" smtClean="0"/>
-              <a:t>2025/11/1</a:t>
+              <a:t>2025/12/22</a:t>
             </a:fld>
             <a:endParaRPr kumimoji="1" lang="ja-JP" altLang="en-US"/>
           </a:p>
@@ -860,7 +861,7 @@
           <a:p>
             <a:fld id="{27277734-DF0B-5A45-B070-6F76D1CD3B34}" type="datetimeFigureOut">
               <a:rPr kumimoji="1" lang="ja-JP" altLang="en-US" smtClean="0"/>
-              <a:t>2025/11/1</a:t>
+              <a:t>2025/12/22</a:t>
             </a:fld>
             <a:endParaRPr kumimoji="1" lang="ja-JP" altLang="en-US"/>
           </a:p>
@@ -1106,7 +1107,7 @@
           <a:p>
             <a:fld id="{27277734-DF0B-5A45-B070-6F76D1CD3B34}" type="datetimeFigureOut">
               <a:rPr kumimoji="1" lang="ja-JP" altLang="en-US" smtClean="0"/>
-              <a:t>2025/11/1</a:t>
+              <a:t>2025/12/22</a:t>
             </a:fld>
             <a:endParaRPr kumimoji="1" lang="ja-JP" altLang="en-US"/>
           </a:p>
@@ -1402,7 +1403,7 @@
           <a:p>
             <a:fld id="{27277734-DF0B-5A45-B070-6F76D1CD3B34}" type="datetimeFigureOut">
               <a:rPr kumimoji="1" lang="ja-JP" altLang="en-US" smtClean="0"/>
-              <a:t>2025/11/1</a:t>
+              <a:t>2025/12/22</a:t>
             </a:fld>
             <a:endParaRPr kumimoji="1" lang="ja-JP" altLang="en-US"/>
           </a:p>
@@ -1833,7 +1834,7 @@
           <a:p>
             <a:fld id="{27277734-DF0B-5A45-B070-6F76D1CD3B34}" type="datetimeFigureOut">
               <a:rPr kumimoji="1" lang="ja-JP" altLang="en-US" smtClean="0"/>
-              <a:t>2025/11/1</a:t>
+              <a:t>2025/12/22</a:t>
             </a:fld>
             <a:endParaRPr kumimoji="1" lang="ja-JP" altLang="en-US"/>
           </a:p>
@@ -1951,7 +1952,7 @@
           <a:p>
             <a:fld id="{27277734-DF0B-5A45-B070-6F76D1CD3B34}" type="datetimeFigureOut">
               <a:rPr kumimoji="1" lang="ja-JP" altLang="en-US" smtClean="0"/>
-              <a:t>2025/11/1</a:t>
+              <a:t>2025/12/22</a:t>
             </a:fld>
             <a:endParaRPr kumimoji="1" lang="ja-JP" altLang="en-US"/>
           </a:p>
@@ -2046,7 +2047,7 @@
           <a:p>
             <a:fld id="{27277734-DF0B-5A45-B070-6F76D1CD3B34}" type="datetimeFigureOut">
               <a:rPr kumimoji="1" lang="ja-JP" altLang="en-US" smtClean="0"/>
-              <a:t>2025/11/1</a:t>
+              <a:t>2025/12/22</a:t>
             </a:fld>
             <a:endParaRPr kumimoji="1" lang="ja-JP" altLang="en-US"/>
           </a:p>
@@ -2355,7 +2356,7 @@
           <a:p>
             <a:fld id="{27277734-DF0B-5A45-B070-6F76D1CD3B34}" type="datetimeFigureOut">
               <a:rPr kumimoji="1" lang="ja-JP" altLang="en-US" smtClean="0"/>
-              <a:t>2025/11/1</a:t>
+              <a:t>2025/12/22</a:t>
             </a:fld>
             <a:endParaRPr kumimoji="1" lang="ja-JP" altLang="en-US"/>
           </a:p>
@@ -2612,7 +2613,7 @@
           <a:p>
             <a:fld id="{27277734-DF0B-5A45-B070-6F76D1CD3B34}" type="datetimeFigureOut">
               <a:rPr kumimoji="1" lang="ja-JP" altLang="en-US" smtClean="0"/>
-              <a:t>2025/11/1</a:t>
+              <a:t>2025/12/22</a:t>
             </a:fld>
             <a:endParaRPr kumimoji="1" lang="ja-JP" altLang="en-US"/>
           </a:p>
@@ -2857,7 +2858,7 @@
           <a:p>
             <a:fld id="{27277734-DF0B-5A45-B070-6F76D1CD3B34}" type="datetimeFigureOut">
               <a:rPr kumimoji="1" lang="ja-JP" altLang="en-US" smtClean="0"/>
-              <a:t>2025/11/1</a:t>
+              <a:t>2025/12/22</a:t>
             </a:fld>
             <a:endParaRPr kumimoji="1" lang="ja-JP" altLang="en-US"/>
           </a:p>
@@ -3897,6 +3898,344 @@
 </p:sld>
 </file>
 
+<file path=ppt/slides/slide3.xml><?xml version="1.0" encoding="utf-8"?>
+<p:sld xmlns:a="http://schemas.openxmlformats.org/drawingml/2006/main" xmlns:r="http://schemas.openxmlformats.org/officeDocument/2006/relationships" xmlns:p="http://schemas.openxmlformats.org/presentationml/2006/main">
+  <p:cSld>
+    <p:spTree>
+      <p:nvGrpSpPr>
+        <p:cNvPr id="1" name=""/>
+        <p:cNvGrpSpPr/>
+        <p:nvPr/>
+      </p:nvGrpSpPr>
+      <p:grpSpPr>
+        <a:xfrm>
+          <a:off x="0" y="0"/>
+          <a:ext cx="0" cy="0"/>
+          <a:chOff x="0" y="0"/>
+          <a:chExt cx="0" cy="0"/>
+        </a:xfrm>
+      </p:grpSpPr>
+      <p:sp>
+        <p:nvSpPr>
+          <p:cNvPr id="5" name="正方形/長方形 4">
+            <a:extLst>
+              <a:ext uri="{FF2B5EF4-FFF2-40B4-BE49-F238E27FC236}">
+                <a16:creationId xmlns:a16="http://schemas.microsoft.com/office/drawing/2014/main" id="{65F09CC6-4E7B-81F0-0FE6-EF1248BC835F}"/>
+              </a:ext>
+            </a:extLst>
+          </p:cNvPr>
+          <p:cNvSpPr/>
+          <p:nvPr/>
+        </p:nvSpPr>
+        <p:spPr>
+          <a:xfrm>
+            <a:off x="94992" y="140679"/>
+            <a:ext cx="1025641" cy="1187939"/>
+          </a:xfrm>
+          <a:prstGeom prst="rect">
+            <a:avLst/>
+          </a:prstGeom>
+          <a:solidFill>
+            <a:schemeClr val="tx1"/>
+          </a:solidFill>
+          <a:ln>
+            <a:noFill/>
+          </a:ln>
+        </p:spPr>
+        <p:style>
+          <a:lnRef idx="2">
+            <a:schemeClr val="accent1">
+              <a:shade val="15000"/>
+            </a:schemeClr>
+          </a:lnRef>
+          <a:fillRef idx="1">
+            <a:schemeClr val="accent1"/>
+          </a:fillRef>
+          <a:effectRef idx="0">
+            <a:schemeClr val="accent1"/>
+          </a:effectRef>
+          <a:fontRef idx="minor">
+            <a:schemeClr val="lt1"/>
+          </a:fontRef>
+        </p:style>
+        <p:txBody>
+          <a:bodyPr rtlCol="0" anchor="ctr"/>
+          <a:lstStyle/>
+          <a:p>
+            <a:pPr algn="ctr"/>
+            <a:endParaRPr kumimoji="1" lang="ja-JP" altLang="en-US"/>
+          </a:p>
+        </p:txBody>
+      </p:sp>
+      <p:sp>
+        <p:nvSpPr>
+          <p:cNvPr id="6" name="角丸四角形 5">
+            <a:extLst>
+              <a:ext uri="{FF2B5EF4-FFF2-40B4-BE49-F238E27FC236}">
+                <a16:creationId xmlns:a16="http://schemas.microsoft.com/office/drawing/2014/main" id="{2D3A37A2-050B-BE0B-8FBA-E5EDBCDF0AA4}"/>
+              </a:ext>
+            </a:extLst>
+          </p:cNvPr>
+          <p:cNvSpPr/>
+          <p:nvPr/>
+        </p:nvSpPr>
+        <p:spPr>
+          <a:xfrm>
+            <a:off x="236216" y="331784"/>
+            <a:ext cx="743191" cy="805728"/>
+          </a:xfrm>
+          <a:prstGeom prst="roundRect">
+            <a:avLst/>
+          </a:prstGeom>
+          <a:noFill/>
+          <a:ln w="12700">
+            <a:solidFill>
+              <a:schemeClr val="bg1"/>
+            </a:solidFill>
+          </a:ln>
+        </p:spPr>
+        <p:style>
+          <a:lnRef idx="2">
+            <a:schemeClr val="accent1">
+              <a:shade val="15000"/>
+            </a:schemeClr>
+          </a:lnRef>
+          <a:fillRef idx="1">
+            <a:schemeClr val="accent1"/>
+          </a:fillRef>
+          <a:effectRef idx="0">
+            <a:schemeClr val="accent1"/>
+          </a:effectRef>
+          <a:fontRef idx="minor">
+            <a:schemeClr val="lt1"/>
+          </a:fontRef>
+        </p:style>
+        <p:txBody>
+          <a:bodyPr rtlCol="0" anchor="ctr"/>
+          <a:lstStyle/>
+          <a:p>
+            <a:pPr algn="ctr"/>
+            <a:endParaRPr kumimoji="1" lang="ja-JP" altLang="en-US"/>
+          </a:p>
+        </p:txBody>
+      </p:sp>
+      <p:sp>
+        <p:nvSpPr>
+          <p:cNvPr id="2" name="タイトル 1">
+            <a:extLst>
+              <a:ext uri="{FF2B5EF4-FFF2-40B4-BE49-F238E27FC236}">
+                <a16:creationId xmlns:a16="http://schemas.microsoft.com/office/drawing/2014/main" id="{87EFA2A9-E6E2-89DC-0F6B-8A5ED67C0B32}"/>
+              </a:ext>
+            </a:extLst>
+          </p:cNvPr>
+          <p:cNvSpPr txBox="1">
+            <a:spLocks/>
+          </p:cNvSpPr>
+          <p:nvPr/>
+        </p:nvSpPr>
+        <p:spPr>
+          <a:xfrm>
+            <a:off x="283122" y="269756"/>
+            <a:ext cx="649380" cy="1058862"/>
+          </a:xfrm>
+          <a:prstGeom prst="rect">
+            <a:avLst/>
+          </a:prstGeom>
+        </p:spPr>
+        <p:txBody>
+          <a:bodyPr anchor="ctr">
+            <a:normAutofit/>
+          </a:bodyPr>
+          <a:lstStyle>
+            <a:lvl1pPr algn="l" defTabSz="386517" rtl="0" eaLnBrk="1" latinLnBrk="0" hangingPunct="1">
+              <a:lnSpc>
+                <a:spcPct val="90000"/>
+              </a:lnSpc>
+              <a:spcBef>
+                <a:spcPct val="0"/>
+              </a:spcBef>
+              <a:buNone/>
+              <a:defRPr kumimoji="1" sz="1860" kern="1200">
+                <a:solidFill>
+                  <a:schemeClr val="tx1"/>
+                </a:solidFill>
+                <a:latin typeface="+mj-lt"/>
+                <a:ea typeface="+mj-ea"/>
+                <a:cs typeface="+mj-cs"/>
+              </a:defRPr>
+            </a:lvl1pPr>
+          </a:lstStyle>
+          <a:p>
+            <a:r>
+              <a:rPr lang="en-US" altLang="ja-JP" sz="6400" b="1" dirty="0">
+                <a:ln>
+                  <a:solidFill>
+                    <a:schemeClr val="bg1">
+                      <a:lumMod val="95000"/>
+                    </a:schemeClr>
+                  </a:solidFill>
+                </a:ln>
+                <a:blipFill dpi="0" rotWithShape="1">
+                  <a:blip r:embed="rId2"/>
+                  <a:srcRect/>
+                  <a:tile tx="0" ty="0" sx="57000" sy="100000" flip="none" algn="tl"/>
+                </a:blipFill>
+                <a:latin typeface="Bauhaus 93" pitchFamily="82" charset="0"/>
+              </a:rPr>
+              <a:t>P</a:t>
+            </a:r>
+            <a:endParaRPr lang="ja-JP" altLang="en-US" sz="6400" b="1">
+              <a:ln>
+                <a:solidFill>
+                  <a:schemeClr val="bg1">
+                    <a:lumMod val="95000"/>
+                  </a:schemeClr>
+                </a:solidFill>
+              </a:ln>
+              <a:blipFill dpi="0" rotWithShape="1">
+                <a:blip r:embed="rId2"/>
+                <a:srcRect/>
+                <a:tile tx="0" ty="0" sx="57000" sy="100000" flip="none" algn="tl"/>
+              </a:blipFill>
+              <a:latin typeface="Bauhaus 93" pitchFamily="82" charset="0"/>
+            </a:endParaRPr>
+          </a:p>
+        </p:txBody>
+      </p:sp>
+      <p:sp>
+        <p:nvSpPr>
+          <p:cNvPr id="4" name="タイトル 1">
+            <a:extLst>
+              <a:ext uri="{FF2B5EF4-FFF2-40B4-BE49-F238E27FC236}">
+                <a16:creationId xmlns:a16="http://schemas.microsoft.com/office/drawing/2014/main" id="{D07071CE-012B-6850-6252-28266B0A8A77}"/>
+              </a:ext>
+            </a:extLst>
+          </p:cNvPr>
+          <p:cNvSpPr txBox="1">
+            <a:spLocks/>
+          </p:cNvSpPr>
+          <p:nvPr/>
+        </p:nvSpPr>
+        <p:spPr>
+          <a:xfrm>
+            <a:off x="1617082" y="269756"/>
+            <a:ext cx="649380" cy="1058862"/>
+          </a:xfrm>
+          <a:prstGeom prst="rect">
+            <a:avLst/>
+          </a:prstGeom>
+        </p:spPr>
+        <p:txBody>
+          <a:bodyPr anchor="ctr">
+            <a:normAutofit/>
+          </a:bodyPr>
+          <a:lstStyle>
+            <a:lvl1pPr algn="l" defTabSz="386517" rtl="0" eaLnBrk="1" latinLnBrk="0" hangingPunct="1">
+              <a:lnSpc>
+                <a:spcPct val="90000"/>
+              </a:lnSpc>
+              <a:spcBef>
+                <a:spcPct val="0"/>
+              </a:spcBef>
+              <a:buNone/>
+              <a:defRPr kumimoji="1" sz="1860" kern="1200">
+                <a:solidFill>
+                  <a:schemeClr val="tx1"/>
+                </a:solidFill>
+                <a:latin typeface="+mj-lt"/>
+                <a:ea typeface="+mj-ea"/>
+                <a:cs typeface="+mj-cs"/>
+              </a:defRPr>
+            </a:lvl1pPr>
+          </a:lstStyle>
+          <a:p>
+            <a:r>
+              <a:rPr lang="en-US" altLang="ja-JP" sz="6400" b="1" dirty="0">
+                <a:blipFill dpi="0" rotWithShape="1">
+                  <a:blip r:embed="rId2"/>
+                  <a:srcRect/>
+                  <a:tile tx="0" ty="0" sx="57000" sy="100000" flip="none" algn="tl"/>
+                </a:blipFill>
+                <a:latin typeface="Bauhaus 93" pitchFamily="82" charset="0"/>
+              </a:rPr>
+              <a:t>P</a:t>
+            </a:r>
+            <a:endParaRPr lang="ja-JP" altLang="en-US" sz="6400" b="1">
+              <a:blipFill dpi="0" rotWithShape="1">
+                <a:blip r:embed="rId2"/>
+                <a:srcRect/>
+                <a:tile tx="0" ty="0" sx="57000" sy="100000" flip="none" algn="tl"/>
+              </a:blipFill>
+              <a:latin typeface="Bauhaus 93" pitchFamily="82" charset="0"/>
+            </a:endParaRPr>
+          </a:p>
+        </p:txBody>
+      </p:sp>
+      <p:sp>
+        <p:nvSpPr>
+          <p:cNvPr id="7" name="角丸四角形 6">
+            <a:extLst>
+              <a:ext uri="{FF2B5EF4-FFF2-40B4-BE49-F238E27FC236}">
+                <a16:creationId xmlns:a16="http://schemas.microsoft.com/office/drawing/2014/main" id="{1617E5BB-C796-8346-FA6E-77538243F623}"/>
+              </a:ext>
+            </a:extLst>
+          </p:cNvPr>
+          <p:cNvSpPr/>
+          <p:nvPr/>
+        </p:nvSpPr>
+        <p:spPr>
+          <a:xfrm>
+            <a:off x="1570176" y="327260"/>
+            <a:ext cx="743191" cy="805728"/>
+          </a:xfrm>
+          <a:prstGeom prst="roundRect">
+            <a:avLst/>
+          </a:prstGeom>
+          <a:noFill/>
+          <a:ln w="12700">
+            <a:solidFill>
+              <a:schemeClr val="tx1"/>
+            </a:solidFill>
+          </a:ln>
+        </p:spPr>
+        <p:style>
+          <a:lnRef idx="2">
+            <a:schemeClr val="accent1">
+              <a:shade val="15000"/>
+            </a:schemeClr>
+          </a:lnRef>
+          <a:fillRef idx="1">
+            <a:schemeClr val="accent1"/>
+          </a:fillRef>
+          <a:effectRef idx="0">
+            <a:schemeClr val="accent1"/>
+          </a:effectRef>
+          <a:fontRef idx="minor">
+            <a:schemeClr val="lt1"/>
+          </a:fontRef>
+        </p:style>
+        <p:txBody>
+          <a:bodyPr rtlCol="0" anchor="ctr"/>
+          <a:lstStyle/>
+          <a:p>
+            <a:pPr algn="ctr"/>
+            <a:endParaRPr kumimoji="1" lang="ja-JP" altLang="en-US"/>
+          </a:p>
+        </p:txBody>
+      </p:sp>
+    </p:spTree>
+    <p:extLst>
+      <p:ext uri="{BB962C8B-B14F-4D97-AF65-F5344CB8AC3E}">
+        <p14:creationId xmlns:p14="http://schemas.microsoft.com/office/powerpoint/2010/main" val="3232208660"/>
+      </p:ext>
+    </p:extLst>
+  </p:cSld>
+  <p:clrMapOvr>
+    <a:masterClrMapping/>
+  </p:clrMapOvr>
+</p:sld>
+</file>
+
 <file path=ppt/theme/theme1.xml><?xml version="1.0" encoding="utf-8"?>
 <a:theme xmlns:a="http://schemas.openxmlformats.org/drawingml/2006/main" name="Office テーマ">
   <a:themeElements>

</xml_diff>